<commit_message>
Enhance app: kurva prediksi 24 jam, diagnostik MAE/jam, tombol unduh, panel About
- Simulasi: kurva prediksi demand sepanjang hari per koridor/hari (pola bimodal)
- Pemodelan: diagnostik MAE per jam + unduh prediksi & perbandingan model
- Beranda: grafik sekilas pola permintaan
- Sidebar: panel Tentang + link GitHub
- PPT slide Deployment: tambah visual kurva prediksi 24 jam

Co-Authored-By: Claude Opus 4.8 <noreply@anthropic.com>
</commit_message>
<xml_diff>
--- a/ppt/TransJakarta_Demand_Prediction_BNSP.pptx
+++ b/ppt/TransJakarta_Demand_Prediction_BNSP.pptx
@@ -1045,7 +1045,7 @@
           <a:p>
             <a:r>
               <a:rPr lang="en-US" dirty="0"/>
-              <a:t>Aplikasi 8 halaman. Arsitektur: model offline, app memuat artefak. Demo fitur simulasi real-time.</a:t>
+              <a:t>Aplikasi 8 halaman. Fitur unggulan: simulasi menghasilkan kurva demand 24 jam. Arsitektur: model offline, app memuat artefak, deploy di Streamlit Cloud.</a:t>
             </a:r>
             <a:endParaRPr lang="en-US" dirty="0"/>
           </a:p>
@@ -6078,18 +6078,120 @@
       </p:sp>
       <p:sp>
         <p:nvSpPr>
-          <p:cNvPr id="21" name="Shape 19"/>
-          <p:cNvSpPr/>
-          <p:nvPr/>
-        </p:nvSpPr>
-        <p:spPr>
-          <a:xfrm>
-            <a:off x="6126480" y="1554480"/>
-            <a:ext cx="5486400" cy="4663440"/>
+          <p:cNvPr id="21" name="Text 19"/>
+          <p:cNvSpPr/>
+          <p:nvPr/>
+        </p:nvSpPr>
+        <p:spPr>
+          <a:xfrm>
+            <a:off x="6035040" y="1572768"/>
+            <a:ext cx="5760720" cy="365760"/>
+          </a:xfrm>
+          <a:prstGeom prst="rect">
+            <a:avLst/>
+          </a:prstGeom>
+          <a:noFill/>
+          <a:ln/>
+        </p:spPr>
+        <p:txBody>
+          <a:bodyPr wrap="square" lIns="0" tIns="0" rIns="0" bIns="0" rtlCol="0" anchor="ctr"/>
+          <a:lstStyle/>
+          <a:p>
+            <a:pPr indent="0" marL="0">
+              <a:buNone/>
+            </a:pPr>
+            <a:r>
+              <a:rPr lang="en-US" sz="1500" b="1" dirty="0">
+                <a:solidFill>
+                  <a:srgbClr val="F26522"/>
+                </a:solidFill>
+                <a:latin typeface="Calibri" pitchFamily="34" charset="0"/>
+                <a:ea typeface="Calibri" pitchFamily="34" charset="-122"/>
+                <a:cs typeface="Calibri" pitchFamily="34" charset="-120"/>
+              </a:rPr>
+              <a:t>⭐ Fitur unggulan — Simulasi Prediksi 24 Jam</a:t>
+            </a:r>
+            <a:endParaRPr lang="en-US" sz="1500" dirty="0"/>
+          </a:p>
+        </p:txBody>
+      </p:sp>
+      <p:pic>
+        <p:nvPicPr>
+          <p:cNvPr id="22" name="Image 0" descr="../assets/fig_day_curve.png">    </p:cNvPr>
+          <p:cNvPicPr>
+            <a:picLocks noChangeAspect="1"/>
+          </p:cNvPicPr>
+          <p:nvPr/>
+        </p:nvPicPr>
+        <p:blipFill>
+          <a:blip r:embed="rId1"/>
+          <a:stretch>
+            <a:fillRect/>
+          </a:stretch>
+        </p:blipFill>
+        <p:spPr>
+          <a:xfrm>
+            <a:off x="6035040" y="1965960"/>
+            <a:ext cx="5760720" cy="2999232"/>
+          </a:xfrm>
+          <a:prstGeom prst="rect">
+            <a:avLst/>
+          </a:prstGeom>
+        </p:spPr>
+      </p:pic>
+      <p:sp>
+        <p:nvSpPr>
+          <p:cNvPr id="23" name="Text 20"/>
+          <p:cNvSpPr/>
+          <p:nvPr/>
+        </p:nvSpPr>
+        <p:spPr>
+          <a:xfrm>
+            <a:off x="6035040" y="5029200"/>
+            <a:ext cx="5760720" cy="640080"/>
+          </a:xfrm>
+          <a:prstGeom prst="rect">
+            <a:avLst/>
+          </a:prstGeom>
+          <a:noFill/>
+          <a:ln/>
+        </p:spPr>
+        <p:txBody>
+          <a:bodyPr wrap="square" lIns="0" tIns="0" rIns="0" bIns="0" rtlCol="0" anchor="ctr"/>
+          <a:lstStyle/>
+          <a:p>
+            <a:pPr indent="0" marL="0">
+              <a:buNone/>
+            </a:pPr>
+            <a:r>
+              <a:rPr lang="en-US" sz="1200" i="1" dirty="0">
+                <a:solidFill>
+                  <a:srgbClr val="6B7A99"/>
+                </a:solidFill>
+                <a:latin typeface="Calibri" pitchFamily="34" charset="0"/>
+                <a:ea typeface="Calibri" pitchFamily="34" charset="-122"/>
+                <a:cs typeface="Calibri" pitchFamily="34" charset="-120"/>
+              </a:rPr>
+              <a:t>Pilih koridor + hari → model menghasilkan kurva permintaan sepanjang hari (puncak jingga = jam sibuk). Bukti model menangkap ritme operasional, bukan sekadar satu angka.</a:t>
+            </a:r>
+            <a:endParaRPr lang="en-US" sz="1200" dirty="0"/>
+          </a:p>
+        </p:txBody>
+      </p:sp>
+      <p:sp>
+        <p:nvSpPr>
+          <p:cNvPr id="24" name="Shape 21"/>
+          <p:cNvSpPr/>
+          <p:nvPr/>
+        </p:nvSpPr>
+        <p:spPr>
+          <a:xfrm>
+            <a:off x="6035040" y="5715000"/>
+            <a:ext cx="5760720" cy="594360"/>
           </a:xfrm>
           <a:prstGeom prst="roundRect">
             <a:avLst>
-              <a:gd name="adj" fmla="val 1765"/>
+              <a:gd name="adj" fmla="val 13846"/>
             </a:avLst>
           </a:prstGeom>
           <a:solidFill>
@@ -6107,30 +6209,30 @@
       </p:sp>
       <p:sp>
         <p:nvSpPr>
-          <p:cNvPr id="22" name="Text 20"/>
-          <p:cNvSpPr/>
-          <p:nvPr/>
-        </p:nvSpPr>
-        <p:spPr>
-          <a:xfrm>
-            <a:off x="6355080" y="1783080"/>
-            <a:ext cx="5029200" cy="365760"/>
-          </a:xfrm>
-          <a:prstGeom prst="rect">
-            <a:avLst/>
-          </a:prstGeom>
-          <a:noFill/>
-          <a:ln/>
-        </p:spPr>
-        <p:txBody>
-          <a:bodyPr wrap="square" lIns="0" tIns="0" rIns="0" bIns="0" rtlCol="0" anchor="ctr"/>
-          <a:lstStyle/>
-          <a:p>
-            <a:pPr indent="0" marL="0">
-              <a:buNone/>
-            </a:pPr>
-            <a:r>
-              <a:rPr lang="en-US" sz="1700" b="1" dirty="0">
+          <p:cNvPr id="25" name="Text 22"/>
+          <p:cNvSpPr/>
+          <p:nvPr/>
+        </p:nvSpPr>
+        <p:spPr>
+          <a:xfrm>
+            <a:off x="6263640" y="5806440"/>
+            <a:ext cx="5349240" cy="411480"/>
+          </a:xfrm>
+          <a:prstGeom prst="rect">
+            <a:avLst/>
+          </a:prstGeom>
+          <a:noFill/>
+          <a:ln/>
+        </p:spPr>
+        <p:txBody>
+          <a:bodyPr wrap="square" lIns="0" tIns="0" rIns="0" bIns="0" rtlCol="0" anchor="ctr"/>
+          <a:lstStyle/>
+          <a:p>
+            <a:pPr indent="0" marL="0">
+              <a:buNone/>
+            </a:pPr>
+            <a:r>
+              <a:rPr lang="en-US" sz="1150" b="1" dirty="0">
                 <a:solidFill>
                   <a:srgbClr val="F26522"/>
                 </a:solidFill>
@@ -6138,42 +6240,13 @@
                 <a:ea typeface="Calibri" pitchFamily="34" charset="-122"/>
                 <a:cs typeface="Calibri" pitchFamily="34" charset="-120"/>
               </a:rPr>
-              <a:t>Arsitektur Deploy</a:t>
-            </a:r>
-            <a:endParaRPr lang="en-US" sz="1700" dirty="0"/>
-          </a:p>
-        </p:txBody>
-      </p:sp>
-      <p:sp>
-        <p:nvSpPr>
-          <p:cNvPr id="23" name="Text 21"/>
-          <p:cNvSpPr/>
-          <p:nvPr/>
-        </p:nvSpPr>
-        <p:spPr>
-          <a:xfrm>
-            <a:off x="6400800" y="2331720"/>
-            <a:ext cx="4937760" cy="2194560"/>
-          </a:xfrm>
-          <a:prstGeom prst="rect">
-            <a:avLst/>
-          </a:prstGeom>
-          <a:noFill/>
-          <a:ln/>
-        </p:spPr>
-        <p:txBody>
-          <a:bodyPr wrap="square" lIns="0" tIns="0" rIns="0" bIns="0" rtlCol="0" anchor="ctr"/>
-          <a:lstStyle/>
-          <a:p>
-            <a:pPr marL="342900" indent="-342900">
-              <a:spcAft>
-                <a:spcPts val="900"/>
-              </a:spcAft>
-              <a:buSzPct val="100000"/>
-              <a:buChar char="•"/>
-            </a:pPr>
-            <a:r>
-              <a:rPr lang="en-US" sz="1400" dirty="0">
+              <a:t>Arsitektur: </a:t>
+            </a:r>
+            <a:pPr indent="0" marL="0">
+              <a:buNone/>
+            </a:pPr>
+            <a:r>
+              <a:rPr lang="en-US" sz="1150" dirty="0">
                 <a:solidFill>
                   <a:srgbClr val="CADCFC"/>
                 </a:solidFill>
@@ -6181,171 +6254,9 @@
                 <a:ea typeface="Calibri" pitchFamily="34" charset="-122"/>
                 <a:cs typeface="Calibri" pitchFamily="34" charset="-120"/>
               </a:rPr>
-              <a:t>Model dilatih offline → disimpan demand_model.pkl</a:t>
-            </a:r>
-            <a:endParaRPr lang="en-US" sz="1400" dirty="0"/>
-          </a:p>
-          <a:p>
-            <a:pPr marL="342900" indent="-342900">
-              <a:spcAft>
-                <a:spcPts val="900"/>
-              </a:spcAft>
-              <a:buSzPct val="100000"/>
-              <a:buChar char="•"/>
-            </a:pPr>
-            <a:r>
-              <a:rPr lang="en-US" sz="1400" dirty="0">
-                <a:solidFill>
-                  <a:srgbClr val="CADCFC"/>
-                </a:solidFill>
-                <a:latin typeface="Calibri" pitchFamily="34" charset="0"/>
-                <a:ea typeface="Calibri" pitchFamily="34" charset="-122"/>
-                <a:cs typeface="Calibri" pitchFamily="34" charset="-120"/>
-              </a:rPr>
-              <a:t>Aplikasi hanya memuat artefak → ringan &amp; cepat</a:t>
-            </a:r>
-            <a:endParaRPr lang="en-US" sz="1400" dirty="0"/>
-          </a:p>
-          <a:p>
-            <a:pPr marL="342900" indent="-342900">
-              <a:spcAft>
-                <a:spcPts val="900"/>
-              </a:spcAft>
-              <a:buSzPct val="100000"/>
-              <a:buChar char="•"/>
-            </a:pPr>
-            <a:r>
-              <a:rPr lang="en-US" sz="1400" dirty="0">
-                <a:solidFill>
-                  <a:srgbClr val="CADCFC"/>
-                </a:solidFill>
-                <a:latin typeface="Calibri" pitchFamily="34" charset="0"/>
-                <a:ea typeface="Calibri" pitchFamily="34" charset="-122"/>
-                <a:cs typeface="Calibri" pitchFamily="34" charset="-120"/>
-              </a:rPr>
-              <a:t>Caching Streamlit (@st.cache_data / _resource)</a:t>
-            </a:r>
-            <a:endParaRPr lang="en-US" sz="1400" dirty="0"/>
-          </a:p>
-          <a:p>
-            <a:pPr marL="342900" indent="-342900">
-              <a:spcAft>
-                <a:spcPts val="900"/>
-              </a:spcAft>
-              <a:buSzPct val="100000"/>
-              <a:buChar char="•"/>
-            </a:pPr>
-            <a:r>
-              <a:rPr lang="en-US" sz="1400" dirty="0">
-                <a:solidFill>
-                  <a:srgbClr val="CADCFC"/>
-                </a:solidFill>
-                <a:latin typeface="Calibri" pitchFamily="34" charset="0"/>
-                <a:ea typeface="Calibri" pitchFamily="34" charset="-122"/>
-                <a:cs typeface="Calibri" pitchFamily="34" charset="-120"/>
-              </a:rPr>
-              <a:t>Tema konsisten biru–putih–jingga</a:t>
-            </a:r>
-            <a:endParaRPr lang="en-US" sz="1400" dirty="0"/>
-          </a:p>
-          <a:p>
-            <a:pPr marL="342900" indent="-342900">
-              <a:spcAft>
-                <a:spcPts val="900"/>
-              </a:spcAft>
-              <a:buSzPct val="100000"/>
-              <a:buChar char="•"/>
-            </a:pPr>
-            <a:r>
-              <a:rPr lang="en-US" sz="1400" dirty="0">
-                <a:solidFill>
-                  <a:srgbClr val="CADCFC"/>
-                </a:solidFill>
-                <a:latin typeface="Calibri" pitchFamily="34" charset="0"/>
-                <a:ea typeface="Calibri" pitchFamily="34" charset="-122"/>
-                <a:cs typeface="Calibri" pitchFamily="34" charset="-120"/>
-              </a:rPr>
-              <a:t>Deploy gratis ke Streamlit Community Cloud</a:t>
-            </a:r>
-            <a:endParaRPr lang="en-US" sz="1400" dirty="0"/>
-          </a:p>
-        </p:txBody>
-      </p:sp>
-      <p:sp>
-        <p:nvSpPr>
-          <p:cNvPr id="24" name="Shape 22"/>
-          <p:cNvSpPr/>
-          <p:nvPr/>
-        </p:nvSpPr>
-        <p:spPr>
-          <a:xfrm>
-            <a:off x="6355080" y="5074920"/>
-            <a:ext cx="5029200" cy="868680"/>
-          </a:xfrm>
-          <a:prstGeom prst="roundRect">
-            <a:avLst>
-              <a:gd name="adj" fmla="val 10526"/>
-            </a:avLst>
-          </a:prstGeom>
-          <a:solidFill>
-            <a:srgbClr val="F26522"/>
-          </a:solidFill>
-          <a:ln/>
-        </p:spPr>
-      </p:sp>
-      <p:sp>
-        <p:nvSpPr>
-          <p:cNvPr id="25" name="Text 23"/>
-          <p:cNvSpPr/>
-          <p:nvPr/>
-        </p:nvSpPr>
-        <p:spPr>
-          <a:xfrm>
-            <a:off x="6355080" y="5074920"/>
-            <a:ext cx="5029200" cy="868680"/>
-          </a:xfrm>
-          <a:prstGeom prst="rect">
-            <a:avLst/>
-          </a:prstGeom>
-          <a:noFill/>
-          <a:ln/>
-        </p:spPr>
-        <p:txBody>
-          <a:bodyPr wrap="square" lIns="0" tIns="0" rIns="0" bIns="0" rtlCol="0" anchor="ctr"/>
-          <a:lstStyle/>
-          <a:p>
-            <a:pPr algn="ctr" indent="0" marL="0">
-              <a:buNone/>
-            </a:pPr>
-            <a:r>
-              <a:rPr lang="en-US" sz="1250" b="1" dirty="0">
-                <a:solidFill>
-                  <a:srgbClr val="FFFFFF"/>
-                </a:solidFill>
-                <a:latin typeface="Calibri" pitchFamily="34" charset="0"/>
-                <a:ea typeface="Calibri" pitchFamily="34" charset="-122"/>
-                <a:cs typeface="Calibri" pitchFamily="34" charset="-120"/>
-              </a:rPr>
-              <a:t>🎯 Fitur unggulan: Simulasi prediksi real-time</a:t>
-            </a:r>
-            <a:endParaRPr lang="en-US" sz="1250" dirty="0"/>
-          </a:p>
-          <a:p>
-            <a:pPr algn="ctr" indent="0" marL="0">
-              <a:buNone/>
-            </a:pPr>
-            <a:r>
-              <a:rPr lang="en-US" sz="1250" b="1" dirty="0">
-                <a:solidFill>
-                  <a:srgbClr val="FFFFFF"/>
-                </a:solidFill>
-                <a:latin typeface="Calibri" pitchFamily="34" charset="0"/>
-                <a:ea typeface="Calibri" pitchFamily="34" charset="-122"/>
-                <a:cs typeface="Calibri" pitchFamily="34" charset="-120"/>
-              </a:rPr>
-              <a:t>pilih koridor + hari + jam → estimasi penumpang</a:t>
-            </a:r>
-            <a:endParaRPr lang="en-US" sz="1250" dirty="0"/>
+              <a:t>model dilatih offline (.pkl) · app memuat artefak + caching · deploy gratis di Streamlit Cloud.</a:t>
+            </a:r>
+            <a:endParaRPr lang="en-US" sz="1150" dirty="0"/>
           </a:p>
         </p:txBody>
       </p:sp>

</xml_diff>